<commit_message>
PC1: los prompts de la entrega son los usados para construir el producto
El prompt de CU-20 sale de la entrega (queda como borrador para PC2). La
sección 7 del documento y la slide de prompts muestran CLAUDE.md, el prompt
de cada sesión y la skill del proyecto; la carpeta de entrega suma la skill.

Co-Authored-By: Claude Opus 5.5 <noreply@anthropic.com>
</commit_message>
<xml_diff>
--- a/07-Entregables/PC1/Rumbo — PC1 (presentación).pptx
+++ b/07-Entregables/PC1/Rumbo — PC1 (presentación).pptx
@@ -1848,7 +1848,7 @@
           <a:p>
             <a:r>
               <a:rPr lang="en-US" dirty="0"/>
-              <a:t>El prompt de CU-20 es una propuesta del equipo (el documento lo tiene completo, con un ejemplo). CLAUDE.md completo va en la carpeta de entrega.</a:t>
+              <a:t>El punto de control pide los prompts usados para construir el producto, que se desarrolla guiado con IA. CLAUDE.md completo y la skill van en la carpeta de entrega (08 · Agentes).</a:t>
             </a:r>
             <a:endParaRPr lang="en-US" dirty="0"/>
           </a:p>
@@ -15176,7 +15176,7 @@
                 <a:ea typeface="Calibri" pitchFamily="34" charset="-122"/>
                 <a:cs typeface="Calibri" pitchFamily="34" charset="-120"/>
               </a:rPr>
-              <a:t>Los prompts</a:t>
+              <a:t>Los prompts con que construimos Rumbo</a:t>
             </a:r>
             <a:endParaRPr lang="en-US" sz="3000" dirty="0"/>
           </a:p>
@@ -15291,11 +15291,11 @@
         <p:spPr>
           <a:xfrm>
             <a:off x="548640" y="1463040"/>
-            <a:ext cx="5760720" cy="4663440"/>
+            <a:ext cx="3566160" cy="3931920"/>
           </a:xfrm>
           <a:prstGeom prst="roundRect">
             <a:avLst>
-              <a:gd name="adj" fmla="val 2353"/>
+              <a:gd name="adj" fmla="val 3077"/>
             </a:avLst>
           </a:prstGeom>
           <a:solidFill>
@@ -15317,8 +15317,8 @@
         </p:nvSpPr>
         <p:spPr>
           <a:xfrm>
-            <a:off x="822960" y="1645920"/>
-            <a:ext cx="5212080" cy="365760"/>
+            <a:off x="777240" y="1645920"/>
+            <a:ext cx="3108960" cy="320040"/>
           </a:xfrm>
           <a:prstGeom prst="rect">
             <a:avLst/>
@@ -15334,7 +15334,7 @@
               <a:buNone/>
             </a:pPr>
             <a:r>
-              <a:rPr lang="en-US" sz="1600" b="1" dirty="0">
+              <a:rPr lang="en-US" sz="1300" b="1" dirty="0">
                 <a:solidFill>
                   <a:srgbClr val="73A5C4"/>
                 </a:solidFill>
@@ -15342,9 +15342,9 @@
                 <a:ea typeface="Calibri" pitchFamily="34" charset="-122"/>
                 <a:cs typeface="Calibri" pitchFamily="34" charset="-120"/>
               </a:rPr>
-              <a:t>Prompt de CU-20 · IA del producto</a:t>
-            </a:r>
-            <a:endParaRPr lang="en-US" sz="1600" dirty="0"/>
+              <a:t>1 · Prompt de sistema</a:t>
+            </a:r>
+            <a:endParaRPr lang="en-US" sz="1300" dirty="0"/>
           </a:p>
         </p:txBody>
       </p:sp>
@@ -15356,24 +15356,24 @@
         </p:nvSpPr>
         <p:spPr>
           <a:xfrm>
-            <a:off x="822960" y="2103120"/>
-            <a:ext cx="5303520" cy="3108960"/>
-          </a:xfrm>
-          <a:prstGeom prst="rect">
-            <a:avLst/>
-          </a:prstGeom>
-          <a:noFill/>
-          <a:ln/>
-        </p:spPr>
-        <p:txBody>
-          <a:bodyPr wrap="square" lIns="0" tIns="0" rIns="0" bIns="0" rtlCol="0" anchor="t"/>
+            <a:off x="777240" y="1965960"/>
+            <a:ext cx="3108960" cy="457200"/>
+          </a:xfrm>
+          <a:prstGeom prst="rect">
+            <a:avLst/>
+          </a:prstGeom>
+          <a:noFill/>
+          <a:ln/>
+        </p:spPr>
+        <p:txBody>
+          <a:bodyPr wrap="square" lIns="0" tIns="0" rIns="0" bIns="0" rtlCol="0" anchor="ctr"/>
           <a:lstStyle/>
           <a:p>
             <a:pPr indent="0" marL="0">
               <a:buNone/>
             </a:pPr>
             <a:r>
-              <a:rPr lang="en-US" sz="1150" dirty="0">
+              <a:rPr lang="en-US" sz="1800" b="1" dirty="0">
                 <a:solidFill>
                   <a:srgbClr val="FFFFFF"/>
                 </a:solidFill>
@@ -15381,269 +15381,115 @@
                 <a:ea typeface="Courier New" pitchFamily="34" charset="-122"/>
                 <a:cs typeface="Courier New" pitchFamily="34" charset="-120"/>
               </a:rPr>
-              <a:t>Sos redactor de contenido para redes sociales de una</a:t>
-            </a:r>
-            <a:endParaRPr lang="en-US" sz="1150" dirty="0"/>
-          </a:p>
-          <a:p>
-            <a:pPr indent="0" marL="0">
-              <a:buNone/>
-            </a:pPr>
-            <a:r>
-              <a:rPr lang="en-US" sz="1150" dirty="0">
+              <a:t>CLAUDE.md</a:t>
+            </a:r>
+            <a:endParaRPr lang="en-US" sz="1800" dirty="0"/>
+          </a:p>
+        </p:txBody>
+      </p:sp>
+      <p:sp>
+        <p:nvSpPr>
+          <p:cNvPr id="10" name="Text 8"/>
+          <p:cNvSpPr txBox="1"/>
+          <p:nvPr/>
+        </p:nvSpPr>
+        <p:spPr>
+          <a:xfrm>
+            <a:off x="777240" y="2606040"/>
+            <a:ext cx="3108960" cy="3291840"/>
+          </a:xfrm>
+          <a:prstGeom prst="rect">
+            <a:avLst/>
+          </a:prstGeom>
+          <a:noFill/>
+          <a:ln/>
+        </p:spPr>
+        <p:txBody>
+          <a:bodyPr wrap="square" lIns="0" tIns="0" rIns="0" bIns="0" rtlCol="0" anchor="t"/>
+          <a:lstStyle/>
+          <a:p>
+            <a:pPr marL="203200" indent="-203200">
+              <a:spcAft>
+                <a:spcPts val="800"/>
+              </a:spcAft>
+              <a:buSzPct val="100000"/>
+              <a:buChar char="•"/>
+            </a:pPr>
+            <a:r>
+              <a:rPr lang="en-US" sz="1350" dirty="0">
                 <a:solidFill>
                   <a:srgbClr val="FFFFFF"/>
                 </a:solidFill>
-                <a:latin typeface="Courier New" pitchFamily="34" charset="0"/>
-                <a:ea typeface="Courier New" pitchFamily="34" charset="-122"/>
-                <a:cs typeface="Courier New" pitchFamily="34" charset="-120"/>
-              </a:rPr>
-              <a:t>agencia de turismo argentina. [...]</a:t>
-            </a:r>
-            <a:endParaRPr lang="en-US" sz="1150" dirty="0"/>
-          </a:p>
-          <a:p>
-            <a:pPr indent="0" marL="0">
-              <a:buNone/>
-            </a:pPr>
-            <a:r>
-              <a:rPr lang="en-US" sz="1150" dirty="0">
+                <a:latin typeface="Calibri" pitchFamily="34" charset="0"/>
+                <a:ea typeface="Calibri" pitchFamily="34" charset="-122"/>
+                <a:cs typeface="Calibri" pitchFamily="34" charset="-120"/>
+              </a:rPr>
+              <a:t>El agente lo lee al empezar cada sesión.</a:t>
+            </a:r>
+            <a:endParaRPr lang="en-US" sz="1350" dirty="0"/>
+          </a:p>
+          <a:p>
+            <a:pPr marL="203200" indent="-203200">
+              <a:spcAft>
+                <a:spcPts val="800"/>
+              </a:spcAft>
+              <a:buSzPct val="100000"/>
+              <a:buChar char="•"/>
+            </a:pPr>
+            <a:r>
+              <a:rPr lang="en-US" sz="1350" dirty="0">
                 <a:solidFill>
                   <a:srgbClr val="FFFFFF"/>
                 </a:solidFill>
-                <a:latin typeface="Courier New" pitchFamily="34" charset="0"/>
-                <a:ea typeface="Courier New" pitchFamily="34" charset="-122"/>
-                <a:cs typeface="Courier New" pitchFamily="34" charset="-120"/>
-              </a:rPr>
-              <a:t>Proponé UN borrador a partir del tema, el canal y el tono.</a:t>
-            </a:r>
-            <a:endParaRPr lang="en-US" sz="1150" dirty="0"/>
-          </a:p>
-          <a:p>
-            <a:pPr indent="0" marL="0">
-              <a:buNone/>
-            </a:pPr>
-            <a:r>
-              <a:rPr lang="en-US" sz="1150" dirty="0">
+                <a:latin typeface="Calibri" pitchFamily="34" charset="0"/>
+                <a:ea typeface="Calibri" pitchFamily="34" charset="-122"/>
+                <a:cs typeface="Calibri" pitchFamily="34" charset="-120"/>
+              </a:rPr>
+              <a:t>Cómo entrar en contexto: identificar a la persona, traer el trabajo del equipo y leer el estado.</a:t>
+            </a:r>
+            <a:endParaRPr lang="en-US" sz="1350" dirty="0"/>
+          </a:p>
+          <a:p>
+            <a:pPr marL="203200" indent="-203200">
+              <a:spcAft>
+                <a:spcPts val="800"/>
+              </a:spcAft>
+              <a:buSzPct val="100000"/>
+              <a:buChar char="•"/>
+            </a:pPr>
+            <a:r>
+              <a:rPr lang="en-US" sz="1350" dirty="0">
                 <a:solidFill>
                   <a:srgbClr val="FFFFFF"/>
                 </a:solidFill>
-                <a:latin typeface="Courier New" pitchFamily="34" charset="0"/>
-                <a:ea typeface="Courier New" pitchFamily="34" charset="-122"/>
-                <a:cs typeface="Courier New" pitchFamily="34" charset="-120"/>
-              </a:rPr>
-              <a:t>- Usá solo la información del pedido: no inventes</a:t>
-            </a:r>
-            <a:endParaRPr lang="en-US" sz="1150" dirty="0"/>
-          </a:p>
-          <a:p>
-            <a:pPr indent="0" marL="0">
-              <a:buNone/>
-            </a:pPr>
-            <a:r>
-              <a:rPr lang="en-US" sz="1150" dirty="0">
+                <a:latin typeface="Calibri" pitchFamily="34" charset="0"/>
+                <a:ea typeface="Calibri" pitchFamily="34" charset="-122"/>
+                <a:cs typeface="Calibri" pitchFamily="34" charset="-120"/>
+              </a:rPr>
+              <a:t>Reglas: respetar el alcance, no inventar datos del negocio y no aprobar nada sin el equipo.</a:t>
+            </a:r>
+            <a:endParaRPr lang="en-US" sz="1350" dirty="0"/>
+          </a:p>
+          <a:p>
+            <a:pPr marL="203200" indent="-203200">
+              <a:spcAft>
+                <a:spcPts val="800"/>
+              </a:spcAft>
+              <a:buSzPct val="100000"/>
+              <a:buChar char="•"/>
+            </a:pPr>
+            <a:r>
+              <a:rPr lang="en-US" sz="1350" dirty="0">
                 <a:solidFill>
                   <a:srgbClr val="FFFFFF"/>
                 </a:solidFill>
-                <a:latin typeface="Courier New" pitchFamily="34" charset="0"/>
-                <a:ea typeface="Courier New" pitchFamily="34" charset="-122"/>
-                <a:cs typeface="Courier New" pitchFamily="34" charset="-120"/>
-              </a:rPr>
-              <a:t>  precios, fechas ni cupos. Si falta un dato, dejá</a:t>
-            </a:r>
-            <a:endParaRPr lang="en-US" sz="1150" dirty="0"/>
-          </a:p>
-          <a:p>
-            <a:pPr indent="0" marL="0">
-              <a:buNone/>
-            </a:pPr>
-            <a:r>
-              <a:rPr lang="en-US" sz="1150" dirty="0">
-                <a:solidFill>
-                  <a:srgbClr val="FFFFFF"/>
-                </a:solidFill>
-                <a:latin typeface="Courier New" pitchFamily="34" charset="0"/>
-                <a:ea typeface="Courier New" pitchFamily="34" charset="-122"/>
-                <a:cs typeface="Courier New" pitchFamily="34" charset="-120"/>
-              </a:rPr>
-              <a:t>  un marcador: [precio], [fecha de salida].</a:t>
-            </a:r>
-            <a:endParaRPr lang="en-US" sz="1150" dirty="0"/>
-          </a:p>
-          <a:p>
-            <a:pPr indent="0" marL="0">
-              <a:buNone/>
-            </a:pPr>
-            <a:r>
-              <a:rPr lang="en-US" sz="1150" dirty="0">
-                <a:solidFill>
-                  <a:srgbClr val="FFFFFF"/>
-                </a:solidFill>
-                <a:latin typeface="Courier New" pitchFamily="34" charset="0"/>
-                <a:ea typeface="Courier New" pitchFamily="34" charset="-122"/>
-                <a:cs typeface="Courier New" pitchFamily="34" charset="-120"/>
-              </a:rPr>
-              <a:t>- No incluyas datos personales de clientes.</a:t>
-            </a:r>
-            <a:endParaRPr lang="en-US" sz="1150" dirty="0"/>
-          </a:p>
-          <a:p>
-            <a:pPr indent="0" marL="0">
-              <a:buNone/>
-            </a:pPr>
-            <a:r>
-              <a:rPr lang="en-US" sz="1150" dirty="0">
-                <a:solidFill>
-                  <a:srgbClr val="FFFFFF"/>
-                </a:solidFill>
-                <a:latin typeface="Courier New" pitchFamily="34" charset="0"/>
-                <a:ea typeface="Courier New" pitchFamily="34" charset="-122"/>
-                <a:cs typeface="Courier New" pitchFamily="34" charset="-120"/>
-              </a:rPr>
-              <a:t>- Adaptá el formato al canal:</a:t>
-            </a:r>
-            <a:endParaRPr lang="en-US" sz="1150" dirty="0"/>
-          </a:p>
-          <a:p>
-            <a:pPr indent="0" marL="0">
-              <a:buNone/>
-            </a:pPr>
-            <a:r>
-              <a:rPr lang="en-US" sz="1150" dirty="0">
-                <a:solidFill>
-                  <a:srgbClr val="FFFFFF"/>
-                </a:solidFill>
-                <a:latin typeface="Courier New" pitchFamily="34" charset="0"/>
-                <a:ea typeface="Courier New" pitchFamily="34" charset="-122"/>
-                <a:cs typeface="Courier New" pitchFamily="34" charset="-120"/>
-              </a:rPr>
-              <a:t>  instagram: hasta 120 palabras, llamada a la</a:t>
-            </a:r>
-            <a:endParaRPr lang="en-US" sz="1150" dirty="0"/>
-          </a:p>
-          <a:p>
-            <a:pPr indent="0" marL="0">
-              <a:buNone/>
-            </a:pPr>
-            <a:r>
-              <a:rPr lang="en-US" sz="1150" dirty="0">
-                <a:solidFill>
-                  <a:srgbClr val="FFFFFF"/>
-                </a:solidFill>
-                <a:latin typeface="Courier New" pitchFamily="34" charset="0"/>
-                <a:ea typeface="Courier New" pitchFamily="34" charset="-122"/>
-                <a:cs typeface="Courier New" pitchFamily="34" charset="-120"/>
-              </a:rPr>
-              <a:t>    acción y entre 3 y 6 hashtags.</a:t>
-            </a:r>
-            <a:endParaRPr lang="en-US" sz="1150" dirty="0"/>
-          </a:p>
-          <a:p>
-            <a:pPr indent="0" marL="0">
-              <a:buNone/>
-            </a:pPr>
-            <a:r>
-              <a:rPr lang="en-US" sz="1150" dirty="0">
-                <a:solidFill>
-                  <a:srgbClr val="FFFFFF"/>
-                </a:solidFill>
-                <a:latin typeface="Courier New" pitchFamily="34" charset="0"/>
-                <a:ea typeface="Courier New" pitchFamily="34" charset="-122"/>
-                <a:cs typeface="Courier New" pitchFamily="34" charset="-120"/>
-              </a:rPr>
-              <a:t>  tiktok: guion de 15 a 30 segundos en escenas.</a:t>
-            </a:r>
-            <a:endParaRPr lang="en-US" sz="1150" dirty="0"/>
-          </a:p>
-          <a:p>
-            <a:pPr indent="0" marL="0">
-              <a:buNone/>
-            </a:pPr>
-            <a:r>
-              <a:rPr lang="en-US" sz="1150" dirty="0">
-                <a:solidFill>
-                  <a:srgbClr val="FFFFFF"/>
-                </a:solidFill>
-                <a:latin typeface="Courier New" pitchFamily="34" charset="0"/>
-                <a:ea typeface="Courier New" pitchFamily="34" charset="-122"/>
-                <a:cs typeface="Courier New" pitchFamily="34" charset="-120"/>
-              </a:rPr>
-              <a:t>  whatsapp_ventas: hasta 60 palabras, sin</a:t>
-            </a:r>
-            <a:endParaRPr lang="en-US" sz="1150" dirty="0"/>
-          </a:p>
-          <a:p>
-            <a:pPr indent="0" marL="0">
-              <a:buNone/>
-            </a:pPr>
-            <a:r>
-              <a:rPr lang="en-US" sz="1150" dirty="0">
-                <a:solidFill>
-                  <a:srgbClr val="FFFFFF"/>
-                </a:solidFill>
-                <a:latin typeface="Courier New" pitchFamily="34" charset="0"/>
-                <a:ea typeface="Courier New" pitchFamily="34" charset="-122"/>
-                <a:cs typeface="Courier New" pitchFamily="34" charset="-120"/>
-              </a:rPr>
-              <a:t>    hashtags, con una pregunta final.</a:t>
-            </a:r>
-            <a:endParaRPr lang="en-US" sz="1150" dirty="0"/>
-          </a:p>
-          <a:p>
-            <a:pPr indent="0" marL="0">
-              <a:buNone/>
-            </a:pPr>
-            <a:r>
-              <a:rPr lang="en-US" sz="1150" dirty="0">
-                <a:solidFill>
-                  <a:srgbClr val="FFFFFF"/>
-                </a:solidFill>
-                <a:latin typeface="Courier New" pitchFamily="34" charset="0"/>
-                <a:ea typeface="Courier New" pitchFamily="34" charset="-122"/>
-                <a:cs typeface="Courier New" pitchFamily="34" charset="-120"/>
-              </a:rPr>
-              <a:t>- No publicás nada: una persona revisa y publica.</a:t>
-            </a:r>
-            <a:endParaRPr lang="en-US" sz="1150" dirty="0"/>
-          </a:p>
-        </p:txBody>
-      </p:sp>
-      <p:sp>
-        <p:nvSpPr>
-          <p:cNvPr id="10" name="Text 8"/>
-          <p:cNvSpPr txBox="1"/>
-          <p:nvPr/>
-        </p:nvSpPr>
-        <p:spPr>
-          <a:xfrm>
-            <a:off x="822960" y="5303520"/>
-            <a:ext cx="5303520" cy="457200"/>
-          </a:xfrm>
-          <a:prstGeom prst="rect">
-            <a:avLst/>
-          </a:prstGeom>
-          <a:noFill/>
-          <a:ln/>
-        </p:spPr>
-        <p:txBody>
-          <a:bodyPr wrap="square" lIns="0" tIns="0" rIns="0" bIns="0" rtlCol="0" anchor="ctr"/>
-          <a:lstStyle/>
-          <a:p>
-            <a:pPr indent="0" marL="0">
-              <a:buNone/>
-            </a:pPr>
-            <a:r>
-              <a:rPr lang="en-US" sz="1150" b="1" dirty="0">
-                <a:solidFill>
-                  <a:srgbClr val="E8A93A"/>
-                </a:solidFill>
-                <a:latin typeface="Courier New" pitchFamily="34" charset="0"/>
-                <a:ea typeface="Courier New" pitchFamily="34" charset="-122"/>
-                <a:cs typeface="Courier New" pitchFamily="34" charset="-120"/>
-              </a:rPr>
-              <a:t>Tema: {tema} · Canal: {canal} · Tono: {tono}</a:t>
-            </a:r>
-            <a:endParaRPr lang="en-US" sz="1150" dirty="0"/>
+                <a:latin typeface="Calibri" pitchFamily="34" charset="0"/>
+                <a:ea typeface="Calibri" pitchFamily="34" charset="-122"/>
+                <a:cs typeface="Calibri" pitchFamily="34" charset="-120"/>
+              </a:rPr>
+              <a:t>Cómo cerrar: bitácora, commit con la identidad de la persona y subir.</a:t>
+            </a:r>
+            <a:endParaRPr lang="en-US" sz="1350" dirty="0"/>
           </a:p>
         </p:txBody>
       </p:sp>
@@ -15655,12 +15501,12 @@
         </p:nvSpPr>
         <p:spPr>
           <a:xfrm>
-            <a:off x="6583680" y="1463040"/>
-            <a:ext cx="5056632" cy="4663440"/>
+            <a:off x="4306824" y="1463040"/>
+            <a:ext cx="3566160" cy="3931920"/>
           </a:xfrm>
           <a:prstGeom prst="roundRect">
             <a:avLst>
-              <a:gd name="adj" fmla="val 2353"/>
+              <a:gd name="adj" fmla="val 3077"/>
             </a:avLst>
           </a:prstGeom>
           <a:solidFill>
@@ -15682,8 +15528,8 @@
         </p:nvSpPr>
         <p:spPr>
           <a:xfrm>
-            <a:off x="6858000" y="1645920"/>
-            <a:ext cx="4572000" cy="365760"/>
+            <a:off x="4535424" y="1645920"/>
+            <a:ext cx="3108960" cy="320040"/>
           </a:xfrm>
           <a:prstGeom prst="rect">
             <a:avLst/>
@@ -15699,7 +15545,46 @@
               <a:buNone/>
             </a:pPr>
             <a:r>
-              <a:rPr lang="en-US" sz="1600" b="1" dirty="0">
+              <a:rPr lang="en-US" sz="1300" b="1" dirty="0">
+                <a:solidFill>
+                  <a:srgbClr val="3E7196"/>
+                </a:solidFill>
+                <a:latin typeface="Calibri" pitchFamily="34" charset="0"/>
+                <a:ea typeface="Calibri" pitchFamily="34" charset="-122"/>
+                <a:cs typeface="Calibri" pitchFamily="34" charset="-120"/>
+              </a:rPr>
+              <a:t>2 · Prompt de cada sesión</a:t>
+            </a:r>
+            <a:endParaRPr lang="en-US" sz="1300" dirty="0"/>
+          </a:p>
+        </p:txBody>
+      </p:sp>
+      <p:sp>
+        <p:nvSpPr>
+          <p:cNvPr id="13" name="Text 11"/>
+          <p:cNvSpPr txBox="1"/>
+          <p:nvPr/>
+        </p:nvSpPr>
+        <p:spPr>
+          <a:xfrm>
+            <a:off x="4535424" y="1965960"/>
+            <a:ext cx="3108960" cy="457200"/>
+          </a:xfrm>
+          <a:prstGeom prst="rect">
+            <a:avLst/>
+          </a:prstGeom>
+          <a:noFill/>
+          <a:ln/>
+        </p:spPr>
+        <p:txBody>
+          <a:bodyPr wrap="square" lIns="0" tIns="0" rIns="0" bIns="0" rtlCol="0" anchor="ctr"/>
+          <a:lstStyle/>
+          <a:p>
+            <a:pPr indent="0" marL="0">
+              <a:buNone/>
+            </a:pPr>
+            <a:r>
+              <a:rPr lang="en-US" sz="1700" b="1" i="1" dirty="0">
                 <a:solidFill>
                   <a:srgbClr val="17354C"/>
                 </a:solidFill>
@@ -15707,22 +15592,22 @@
                 <a:ea typeface="Calibri" pitchFamily="34" charset="-122"/>
                 <a:cs typeface="Calibri" pitchFamily="34" charset="-120"/>
               </a:rPr>
-              <a:t>CLAUDE.md · prompt del agente de desarrollo</a:t>
-            </a:r>
-            <a:endParaRPr lang="en-US" sz="1600" dirty="0"/>
-          </a:p>
-        </p:txBody>
-      </p:sp>
-      <p:sp>
-        <p:nvSpPr>
-          <p:cNvPr id="13" name="Text 11"/>
-          <p:cNvSpPr txBox="1"/>
-          <p:nvPr/>
-        </p:nvSpPr>
-        <p:spPr>
-          <a:xfrm>
-            <a:off x="6858000" y="2148840"/>
-            <a:ext cx="4572000" cy="3749040"/>
+              <a:t>«Hola, entrá en contexto.»</a:t>
+            </a:r>
+            <a:endParaRPr lang="en-US" sz="1700" dirty="0"/>
+          </a:p>
+        </p:txBody>
+      </p:sp>
+      <p:sp>
+        <p:nvSpPr>
+          <p:cNvPr id="14" name="Text 12"/>
+          <p:cNvSpPr txBox="1"/>
+          <p:nvPr/>
+        </p:nvSpPr>
+        <p:spPr>
+          <a:xfrm>
+            <a:off x="4535424" y="2606040"/>
+            <a:ext cx="3108960" cy="3291840"/>
           </a:xfrm>
           <a:prstGeom prst="rect">
             <a:avLst/>
@@ -15742,7 +15627,7 @@
               <a:buChar char="•"/>
             </a:pPr>
             <a:r>
-              <a:rPr lang="en-US" sz="1400" dirty="0">
+              <a:rPr lang="en-US" sz="1350" dirty="0">
                 <a:solidFill>
                   <a:srgbClr val="1F2A33"/>
                 </a:solidFill>
@@ -15750,9 +15635,9 @@
                 <a:ea typeface="Calibri" pitchFamily="34" charset="-122"/>
                 <a:cs typeface="Calibri" pitchFamily="34" charset="-120"/>
               </a:rPr>
-              <a:t>Claude Code lo lee al empezar cada sesión: es su prompt de sistema para este proyecto.</a:t>
-            </a:r>
-            <a:endParaRPr lang="en-US" sz="1400" dirty="0"/>
+              <a:t>Con CLAUDE.md alcanza un pedido corto: el agente aplica el protocolo solo.</a:t>
+            </a:r>
+            <a:endParaRPr lang="en-US" sz="1350" dirty="0"/>
           </a:p>
           <a:p>
             <a:pPr marL="203200" indent="-203200">
@@ -15763,7 +15648,7 @@
               <a:buChar char="•"/>
             </a:pPr>
             <a:r>
-              <a:rPr lang="en-US" sz="1400" dirty="0">
+              <a:rPr lang="en-US" sz="1350" dirty="0">
                 <a:solidFill>
                   <a:srgbClr val="1F2A33"/>
                 </a:solidFill>
@@ -15771,9 +15656,9 @@
                 <a:ea typeface="Calibri" pitchFamily="34" charset="-122"/>
                 <a:cs typeface="Calibri" pitchFamily="34" charset="-120"/>
               </a:rPr>
-              <a:t>Cómo entrar en contexto: identificar a la persona, traer el trabajo del equipo y leer el estado.</a:t>
-            </a:r>
-            <a:endParaRPr lang="en-US" sz="1400" dirty="0"/>
+              <a:t>Después, cada pedido describe la tarea: «revisemos y decime qué falta».</a:t>
+            </a:r>
+            <a:endParaRPr lang="en-US" sz="1350" dirty="0"/>
           </a:p>
           <a:p>
             <a:pPr marL="203200" indent="-203200">
@@ -15784,7 +15669,7 @@
               <a:buChar char="•"/>
             </a:pPr>
             <a:r>
-              <a:rPr lang="en-US" sz="1400" dirty="0">
+              <a:rPr lang="en-US" sz="1350" dirty="0">
                 <a:solidFill>
                   <a:srgbClr val="1F2A33"/>
                 </a:solidFill>
@@ -15792,10 +15677,137 @@
                 <a:ea typeface="Calibri" pitchFamily="34" charset="-122"/>
                 <a:cs typeface="Calibri" pitchFamily="34" charset="-120"/>
               </a:rPr>
-              <a:t>Reglas: respetar el alcance, no inventar datos del negocio y no aprobar nada sin el equipo.</a:t>
-            </a:r>
-            <a:endParaRPr lang="en-US" sz="1400" dirty="0"/>
-          </a:p>
+              <a:t>Fuera de Claude Code, un prompt inicial le indica qué leer y qué no formalizar.</a:t>
+            </a:r>
+            <a:endParaRPr lang="en-US" sz="1350" dirty="0"/>
+          </a:p>
+        </p:txBody>
+      </p:sp>
+      <p:sp>
+        <p:nvSpPr>
+          <p:cNvPr id="15" name="Shape 13"/>
+          <p:cNvSpPr/>
+          <p:nvPr/>
+        </p:nvSpPr>
+        <p:spPr>
+          <a:xfrm>
+            <a:off x="8065008" y="1463040"/>
+            <a:ext cx="3566160" cy="3931920"/>
+          </a:xfrm>
+          <a:prstGeom prst="roundRect">
+            <a:avLst>
+              <a:gd name="adj" fmla="val 3077"/>
+            </a:avLst>
+          </a:prstGeom>
+          <a:solidFill>
+            <a:srgbClr val="FFFFFF"/>
+          </a:solidFill>
+          <a:ln w="9525">
+            <a:solidFill>
+              <a:srgbClr val="E3E8ED"/>
+            </a:solidFill>
+            <a:prstDash val="solid"/>
+          </a:ln>
+        </p:spPr>
+      </p:sp>
+      <p:sp>
+        <p:nvSpPr>
+          <p:cNvPr id="16" name="Text 14"/>
+          <p:cNvSpPr txBox="1"/>
+          <p:nvPr/>
+        </p:nvSpPr>
+        <p:spPr>
+          <a:xfrm>
+            <a:off x="8293608" y="1645920"/>
+            <a:ext cx="3108960" cy="320040"/>
+          </a:xfrm>
+          <a:prstGeom prst="rect">
+            <a:avLst/>
+          </a:prstGeom>
+          <a:noFill/>
+          <a:ln/>
+        </p:spPr>
+        <p:txBody>
+          <a:bodyPr wrap="square" lIns="0" tIns="0" rIns="0" bIns="0" rtlCol="0" anchor="ctr"/>
+          <a:lstStyle/>
+          <a:p>
+            <a:pPr indent="0" marL="0">
+              <a:buNone/>
+            </a:pPr>
+            <a:r>
+              <a:rPr lang="en-US" sz="1300" b="1" dirty="0">
+                <a:solidFill>
+                  <a:srgbClr val="3E7196"/>
+                </a:solidFill>
+                <a:latin typeface="Calibri" pitchFamily="34" charset="0"/>
+                <a:ea typeface="Calibri" pitchFamily="34" charset="-122"/>
+                <a:cs typeface="Calibri" pitchFamily="34" charset="-120"/>
+              </a:rPr>
+              <a:t>3 · Prompts reutilizables</a:t>
+            </a:r>
+            <a:endParaRPr lang="en-US" sz="1300" dirty="0"/>
+          </a:p>
+        </p:txBody>
+      </p:sp>
+      <p:sp>
+        <p:nvSpPr>
+          <p:cNvPr id="17" name="Text 15"/>
+          <p:cNvSpPr txBox="1"/>
+          <p:nvPr/>
+        </p:nvSpPr>
+        <p:spPr>
+          <a:xfrm>
+            <a:off x="8293608" y="1965960"/>
+            <a:ext cx="3108960" cy="457200"/>
+          </a:xfrm>
+          <a:prstGeom prst="rect">
+            <a:avLst/>
+          </a:prstGeom>
+          <a:noFill/>
+          <a:ln/>
+        </p:spPr>
+        <p:txBody>
+          <a:bodyPr wrap="square" lIns="0" tIns="0" rIns="0" bIns="0" rtlCol="0" anchor="ctr"/>
+          <a:lstStyle/>
+          <a:p>
+            <a:pPr indent="0" marL="0">
+              <a:buNone/>
+            </a:pPr>
+            <a:r>
+              <a:rPr lang="en-US" sz="1800" b="1" dirty="0">
+                <a:solidFill>
+                  <a:srgbClr val="17354C"/>
+                </a:solidFill>
+                <a:latin typeface="Courier New" pitchFamily="34" charset="0"/>
+                <a:ea typeface="Courier New" pitchFamily="34" charset="-122"/>
+                <a:cs typeface="Courier New" pitchFamily="34" charset="-120"/>
+              </a:rPr>
+              <a:t>Skills del proyecto</a:t>
+            </a:r>
+            <a:endParaRPr lang="en-US" sz="1800" dirty="0"/>
+          </a:p>
+        </p:txBody>
+      </p:sp>
+      <p:sp>
+        <p:nvSpPr>
+          <p:cNvPr id="18" name="Text 16"/>
+          <p:cNvSpPr txBox="1"/>
+          <p:nvPr/>
+        </p:nvSpPr>
+        <p:spPr>
+          <a:xfrm>
+            <a:off x="8293608" y="2606040"/>
+            <a:ext cx="3108960" cy="3291840"/>
+          </a:xfrm>
+          <a:prstGeom prst="rect">
+            <a:avLst/>
+          </a:prstGeom>
+          <a:noFill/>
+          <a:ln/>
+        </p:spPr>
+        <p:txBody>
+          <a:bodyPr wrap="square" lIns="0" tIns="0" rIns="0" bIns="0" rtlCol="0" anchor="t"/>
+          <a:lstStyle/>
           <a:p>
             <a:pPr marL="203200" indent="-203200">
               <a:spcAft>
@@ -15805,7 +15817,7 @@
               <a:buChar char="•"/>
             </a:pPr>
             <a:r>
-              <a:rPr lang="en-US" sz="1400" dirty="0">
+              <a:rPr lang="en-US" sz="1350" dirty="0">
                 <a:solidFill>
                   <a:srgbClr val="1F2A33"/>
                 </a:solidFill>
@@ -15813,9 +15825,51 @@
                 <a:ea typeface="Calibri" pitchFamily="34" charset="-122"/>
                 <a:cs typeface="Calibri" pitchFamily="34" charset="-120"/>
               </a:rPr>
-              <a:t>Cómo cerrar: registrar en la bitácora, hacer commit con la identidad de la persona y subir.</a:t>
-            </a:r>
-            <a:endParaRPr lang="en-US" sz="1400" dirty="0"/>
+              <a:t>Un procedimiento que se repite se escribe una vez como skill, versionada en el repositorio.</a:t>
+            </a:r>
+            <a:endParaRPr lang="en-US" sz="1350" dirty="0"/>
+          </a:p>
+          <a:p>
+            <a:pPr marL="203200" indent="-203200">
+              <a:spcAft>
+                <a:spcPts val="800"/>
+              </a:spcAft>
+              <a:buSzPct val="100000"/>
+              <a:buChar char="•"/>
+            </a:pPr>
+            <a:r>
+              <a:rPr lang="en-US" sz="1350" dirty="0">
+                <a:solidFill>
+                  <a:srgbClr val="1F2A33"/>
+                </a:solidFill>
+                <a:latin typeface="Calibri" pitchFamily="34" charset="0"/>
+                <a:ea typeface="Calibri" pitchFamily="34" charset="-122"/>
+                <a:cs typeface="Calibri" pitchFamily="34" charset="-120"/>
+              </a:rPr>
+              <a:t>Ejemplo: gestionar-skills, para incorporar una skill nueva con su origen, versión y licencia.</a:t>
+            </a:r>
+            <a:endParaRPr lang="en-US" sz="1350" dirty="0"/>
+          </a:p>
+          <a:p>
+            <a:pPr marL="203200" indent="-203200">
+              <a:spcAft>
+                <a:spcPts val="800"/>
+              </a:spcAft>
+              <a:buSzPct val="100000"/>
+              <a:buChar char="•"/>
+            </a:pPr>
+            <a:r>
+              <a:rPr lang="en-US" sz="1350" dirty="0">
+                <a:solidFill>
+                  <a:srgbClr val="1F2A33"/>
+                </a:solidFill>
+                <a:latin typeface="Calibri" pitchFamily="34" charset="0"/>
+                <a:ea typeface="Calibri" pitchFamily="34" charset="-122"/>
+                <a:cs typeface="Calibri" pitchFamily="34" charset="-120"/>
+              </a:rPr>
+              <a:t>Mismo pedido, mismo resultado, para cualquier integrante.</a:t>
+            </a:r>
+            <a:endParaRPr lang="en-US" sz="1350" dirty="0"/>
           </a:p>
         </p:txBody>
       </p:sp>

</xml_diff>

<commit_message>
PC1: listas anidadas en los entregables y dueña actualizada en el deck
El filtro de los scripts build-*.sh comprimía la sangría del principio de
línea y aplanaba las sublistas; ahora solo compacta espacios dentro del texto.
Slide «Una vista por perfil»: la dueña tiene todo lo del admin (sync 30/09).
Documento principal, deck y PDF regenerados.

Co-Authored-By: Claude Opus 5.5 <noreply@anthropic.com>
</commit_message>
<xml_diff>
--- a/07-Entregables/PC1/Rumbo — PC1 (presentación).pptx
+++ b/07-Entregables/PC1/Rumbo — PC1 (presentación).pptx
@@ -3696,7 +3696,7 @@
       </p:sp>
       <p:pic>
         <p:nvPicPr>
-          <p:cNvPr id="7" name="Image 0" descr="C:\Users\lucia\OneDrive\Desktop\Trabajo de campo\Vault-Rumbo\07-Entregables\Prototipo\img\03-cu14-agenda.png">    </p:cNvPr>
+          <p:cNvPr id="7" name="Image 0" descr="C:\Users\Usuario\Desktop\Vault-Rumbo\07-Entregables\Prototipo\img\03-cu14-agenda.png">    </p:cNvPr>
           <p:cNvPicPr>
             <a:picLocks noChangeAspect="1"/>
           </p:cNvPicPr>
@@ -3820,7 +3820,7 @@
       </p:sp>
       <p:pic>
         <p:nvPicPr>
-          <p:cNvPr id="11" name="Image 1" descr="C:\Users\lucia\OneDrive\Desktop\Trabajo de campo\Vault-Rumbo\07-Entregables\Prototipo\img\49-admin-agenda-agencia.png">    </p:cNvPr>
+          <p:cNvPr id="11" name="Image 1" descr="C:\Users\Usuario\Desktop\Vault-Rumbo\07-Entregables\Prototipo\img\49-admin-agenda-agencia.png">    </p:cNvPr>
           <p:cNvPicPr>
             <a:picLocks noChangeAspect="1"/>
           </p:cNvPicPr>
@@ -3944,7 +3944,7 @@
       </p:sp>
       <p:pic>
         <p:nvPicPr>
-          <p:cNvPr id="15" name="Image 2" descr="C:\Users\lucia\OneDrive\Desktop\Trabajo de campo\Vault-Rumbo\07-Entregables\Prototipo\img\28-cu21-dashboard.png">    </p:cNvPr>
+          <p:cNvPr id="15" name="Image 2" descr="C:\Users\Usuario\Desktop\Vault-Rumbo\07-Entregables\Prototipo\img\28-cu21-dashboard.png">    </p:cNvPr>
           <p:cNvPicPr>
             <a:picLocks noChangeAspect="1"/>
           </p:cNvPicPr>
@@ -4060,7 +4060,7 @@
                 <a:ea typeface="Calibri" pitchFamily="34" charset="-122"/>
                 <a:cs typeface="Calibri" pitchFamily="34" charset="-120"/>
               </a:rPr>
-              <a:t>Dashboard y reportes de la empresa</a:t>
+              <a:t>Todo lo del admin, más el dashboard y los reportes de la empresa</a:t>
             </a:r>
             <a:endParaRPr lang="en-US" sz="1300" dirty="0"/>
           </a:p>
@@ -4068,7 +4068,7 @@
       </p:sp>
       <p:pic>
         <p:nvPicPr>
-          <p:cNvPr id="19" name="Image 3" descr="C:\Users\lucia\OneDrive\Desktop\Trabajo de campo\Vault-Rumbo\07-Entregables\Prototipo\img\34-freelance-embudo.png">    </p:cNvPr>
+          <p:cNvPr id="19" name="Image 3" descr="C:\Users\Usuario\Desktop\Vault-Rumbo\07-Entregables\Prototipo\img\34-freelance-embudo.png">    </p:cNvPr>
           <p:cNvPicPr>
             <a:picLocks noChangeAspect="1"/>
           </p:cNvPicPr>
@@ -4402,7 +4402,7 @@
       </p:sp>
       <p:pic>
         <p:nvPicPr>
-          <p:cNvPr id="7" name="Image 0" descr="C:\Users\lucia\OneDrive\Desktop\Trabajo de campo\Vault-Rumbo\07-Entregables\Prototipo\img\35-mobile-agenda.png">    </p:cNvPr>
+          <p:cNvPr id="7" name="Image 0" descr="C:\Users\Usuario\Desktop\Vault-Rumbo\07-Entregables\Prototipo\img\35-mobile-agenda.png">    </p:cNvPr>
           <p:cNvPicPr>
             <a:picLocks noChangeAspect="1"/>
           </p:cNvPicPr>
@@ -4450,7 +4450,7 @@
       </p:sp>
       <p:pic>
         <p:nvPicPr>
-          <p:cNvPr id="9" name="Image 1" descr="C:\Users\lucia\OneDrive\Desktop\Trabajo de campo\Vault-Rumbo\07-Entregables\Prototipo\img\53-mobile-detalle-alerta.png">    </p:cNvPr>
+          <p:cNvPr id="9" name="Image 1" descr="C:\Users\Usuario\Desktop\Vault-Rumbo\07-Entregables\Prototipo\img\53-mobile-detalle-alerta.png">    </p:cNvPr>
           <p:cNvPicPr>
             <a:picLocks noChangeAspect="1"/>
           </p:cNvPicPr>
@@ -4498,7 +4498,7 @@
       </p:sp>
       <p:pic>
         <p:nvPicPr>
-          <p:cNvPr id="11" name="Image 2" descr="C:\Users\lucia\OneDrive\Desktop\Trabajo de campo\Vault-Rumbo\07-Entregables\Prototipo\img\57-mobile-clientes.png">    </p:cNvPr>
+          <p:cNvPr id="11" name="Image 2" descr="C:\Users\Usuario\Desktop\Vault-Rumbo\07-Entregables\Prototipo\img\57-mobile-clientes.png">    </p:cNvPr>
           <p:cNvPicPr>
             <a:picLocks noChangeAspect="1"/>
           </p:cNvPicPr>
@@ -4546,7 +4546,7 @@
       </p:sp>
       <p:pic>
         <p:nvPicPr>
-          <p:cNvPr id="13" name="Image 3" descr="C:\Users\lucia\OneDrive\Desktop\Trabajo de campo\Vault-Rumbo\07-Entregables\Prototipo\img\36-mobile-ficha-cliente.png">    </p:cNvPr>
+          <p:cNvPr id="13" name="Image 3" descr="C:\Users\Usuario\Desktop\Vault-Rumbo\07-Entregables\Prototipo\img\36-mobile-ficha-cliente.png">    </p:cNvPr>
           <p:cNvPicPr>
             <a:picLocks noChangeAspect="1"/>
           </p:cNvPicPr>
@@ -7478,7 +7478,7 @@
       </p:sp>
       <p:pic>
         <p:nvPicPr>
-          <p:cNvPr id="7" name="Image 0" descr="C:\Users\lucia\OneDrive\Desktop\Trabajo de campo\Vault-Rumbo\03-Dominio\Diagramas\Clases\DGM-clases.png">    </p:cNvPr>
+          <p:cNvPr id="7" name="Image 0" descr="C:\Users\Usuario\Desktop\Vault-Rumbo\03-Dominio\Diagramas\Clases\DGM-clases.png">    </p:cNvPr>
           <p:cNvPicPr>
             <a:picLocks noChangeAspect="1"/>
           </p:cNvPicPr>
@@ -7946,7 +7946,7 @@
       </p:sp>
       <p:pic>
         <p:nvPicPr>
-          <p:cNvPr id="7" name="Image 0" descr="C:\Users\lucia\OneDrive\Desktop\Trabajo de campo\Vault-Rumbo\05-Diseño\Arquitectura\img\ARQ-despliegue.png">    </p:cNvPr>
+          <p:cNvPr id="7" name="Image 0" descr="C:\Users\Usuario\Desktop\Vault-Rumbo\05-Diseño\Arquitectura\img\ARQ-despliegue.png">    </p:cNvPr>
           <p:cNvPicPr>
             <a:picLocks noChangeAspect="1"/>
           </p:cNvPicPr>
@@ -8350,7 +8350,7 @@
       </p:sp>
       <p:pic>
         <p:nvPicPr>
-          <p:cNvPr id="7" name="Image 0" descr="C:\Users\lucia\OneDrive\Desktop\Trabajo de campo\Vault-Rumbo\05-Diseño\Arquitectura\img\ARQ-C4-1-contexto.png">    </p:cNvPr>
+          <p:cNvPr id="7" name="Image 0" descr="C:\Users\Usuario\Desktop\Vault-Rumbo\05-Diseño\Arquitectura\img\ARQ-C4-1-contexto.png">    </p:cNvPr>
           <p:cNvPicPr>
             <a:picLocks noChangeAspect="1"/>
           </p:cNvPicPr>
@@ -8374,7 +8374,7 @@
       </p:pic>
       <p:pic>
         <p:nvPicPr>
-          <p:cNvPr id="8" name="Image 1" descr="C:\Users\lucia\OneDrive\Desktop\Trabajo de campo\Vault-Rumbo\05-Diseño\Arquitectura\img\ARQ-C4-2-contenedores.png">    </p:cNvPr>
+          <p:cNvPr id="8" name="Image 1" descr="C:\Users\Usuario\Desktop\Vault-Rumbo\05-Diseño\Arquitectura\img\ARQ-C4-2-contenedores.png">    </p:cNvPr>
           <p:cNvPicPr>
             <a:picLocks noChangeAspect="1"/>
           </p:cNvPicPr>
@@ -8686,7 +8686,7 @@
       </p:sp>
       <p:pic>
         <p:nvPicPr>
-          <p:cNvPr id="7" name="Image 0" descr="C:\Users\lucia\OneDrive\Desktop\Trabajo de campo\Vault-Rumbo\05-Diseño\Arquitectura\img\ARQ-C4-3-componentes.png">    </p:cNvPr>
+          <p:cNvPr id="7" name="Image 0" descr="C:\Users\Usuario\Desktop\Vault-Rumbo\05-Diseño\Arquitectura\img\ARQ-C4-3-componentes.png">    </p:cNvPr>
           <p:cNvPicPr>
             <a:picLocks noChangeAspect="1"/>
           </p:cNvPicPr>
@@ -9048,7 +9048,7 @@
       </p:sp>
       <p:pic>
         <p:nvPicPr>
-          <p:cNvPr id="7" name="Image 0" descr="C:\Users\lucia\OneDrive\Desktop\Trabajo de campo\Vault-Rumbo\03-Dominio\Diagramas\DER\DGM-ER.png">    </p:cNvPr>
+          <p:cNvPr id="7" name="Image 0" descr="C:\Users\Usuario\Desktop\Vault-Rumbo\03-Dominio\Diagramas\DER\DGM-ER.png">    </p:cNvPr>
           <p:cNvPicPr>
             <a:picLocks noChangeAspect="1"/>
           </p:cNvPicPr>
@@ -9535,7 +9535,7 @@
       </p:sp>
       <p:pic>
         <p:nvPicPr>
-          <p:cNvPr id="7" name="Image 0" descr="C:\Users\lucia\OneDrive\Desktop\Trabajo de campo\Vault-Rumbo\05-Diseño\Arquitectura\img\ARQ-MVC.png">    </p:cNvPr>
+          <p:cNvPr id="7" name="Image 0" descr="C:\Users\Usuario\Desktop\Vault-Rumbo\05-Diseño\Arquitectura\img\ARQ-MVC.png">    </p:cNvPr>
           <p:cNvPicPr>
             <a:picLocks noChangeAspect="1"/>
           </p:cNvPicPr>
@@ -16342,7 +16342,7 @@
       </p:sp>
       <p:pic>
         <p:nvPicPr>
-          <p:cNvPr id="10" name="Image 0" descr="C:\Users\lucia\OneDrive\Desktop\Trabajo de campo\Vault-Rumbo\05-Diseño\img\DES-pipeline-calidad.png">    </p:cNvPr>
+          <p:cNvPr id="10" name="Image 0" descr="C:\Users\Usuario\Desktop\Vault-Rumbo\05-Diseño\img\DES-pipeline-calidad.png">    </p:cNvPr>
           <p:cNvPicPr>
             <a:picLocks noChangeAspect="1"/>
           </p:cNvPicPr>
@@ -16615,7 +16615,7 @@
       </p:sp>
       <p:pic>
         <p:nvPicPr>
-          <p:cNvPr id="7" name="Image 0" descr="C:\Users\lucia\OneDrive\Desktop\Trabajo de campo\Vault-Rumbo\05-Diseño\img\DES-iteraciones.png">    </p:cNvPr>
+          <p:cNvPr id="7" name="Image 0" descr="C:\Users\Usuario\Desktop\Vault-Rumbo\05-Diseño\img\DES-iteraciones.png">    </p:cNvPr>
           <p:cNvPicPr>
             <a:picLocks noChangeAspect="1"/>
           </p:cNvPicPr>
@@ -17269,7 +17269,7 @@
       </p:sp>
       <p:pic>
         <p:nvPicPr>
-          <p:cNvPr id="7" name="Image 0" descr="C:\Users\lucia\OneDrive\Desktop\Trabajo de campo\Vault-Rumbo\05-Diseño\img\DES-pipeline-calidad.png">    </p:cNvPr>
+          <p:cNvPr id="7" name="Image 0" descr="C:\Users\Usuario\Desktop\Vault-Rumbo\05-Diseño\img\DES-pipeline-calidad.png">    </p:cNvPr>
           <p:cNvPicPr>
             <a:picLocks noChangeAspect="1"/>
           </p:cNvPicPr>
@@ -26760,7 +26760,7 @@
       </p:sp>
       <p:pic>
         <p:nvPicPr>
-          <p:cNvPr id="7" name="Image 0" descr="C:\Users\lucia\OneDrive\Desktop\Trabajo de campo\Vault-Rumbo\05-Diseño\Arquitectura\img\ARQ-capas-conceptual.png">    </p:cNvPr>
+          <p:cNvPr id="7" name="Image 0" descr="C:\Users\Usuario\Desktop\Vault-Rumbo\05-Diseño\Arquitectura\img\ARQ-capas-conceptual.png">    </p:cNvPr>
           <p:cNvPicPr>
             <a:picLocks noChangeAspect="1"/>
           </p:cNvPicPr>
@@ -27309,7 +27309,7 @@
       </p:sp>
       <p:pic>
         <p:nvPicPr>
-          <p:cNvPr id="7" name="Image 0" descr="C:\Users\lucia\OneDrive\Desktop\Trabajo de campo\Vault-Rumbo\07-Entregables\Prototipo\img\03-cu14-agenda.png">    </p:cNvPr>
+          <p:cNvPr id="7" name="Image 0" descr="C:\Users\Usuario\Desktop\Vault-Rumbo\07-Entregables\Prototipo\img\03-cu14-agenda.png">    </p:cNvPr>
           <p:cNvPicPr>
             <a:picLocks noChangeAspect="1"/>
           </p:cNvPicPr>

</xml_diff>

<commit_message>
PC1: fechas del diagrama de iteraciones (PC2 30/10, PC3 13/11, sin cierre) en la slide 25
Co-Authored-By: Claude Sonnet 5.5 <noreply@anthropic.com>
</commit_message>
<xml_diff>
--- a/07-Entregables/PC1/Rumbo — PC1 (presentación).pptx
+++ b/07-Entregables/PC1/Rumbo — PC1 (presentación).pptx
@@ -15359,8 +15359,8 @@
         </p:blipFill>
         <p:spPr>
           <a:xfrm>
-            <a:off x="1390902" y="1371600"/>
-            <a:ext cx="9407149" cy="2651760"/>
+            <a:off x="1837600" y="1371600"/>
+            <a:ext cx="8513750" cy="2780000"/>
           </a:xfrm>
           <a:prstGeom prst="rect">
             <a:avLst/>

</xml_diff>

<commit_message>
PC1: fechas de PC2 (30/10) y PC3 (13/11) actualizadas en cronograma, deck, documentos y bitácora
Co-Authored-By: Claude Sonnet 5.5 <noreply@anthropic.com>
</commit_message>
<xml_diff>
--- a/07-Entregables/PC1/Rumbo — PC1 (presentación).pptx
+++ b/07-Entregables/PC1/Rumbo — PC1 (presentación).pptx
@@ -1761,7 +1761,7 @@
           <a:p>
             <a:r>
               <a:rPr lang="en-US" dirty="0"/>
-              <a:t>Una iteración por punto de control: PC1 análisis y diseño (02/10), PC2 código (20/11), PC3 pruebas y documentación (04/12). Cada cierre deja un tag en Git.</a:t>
+              <a:t>Una iteración por punto de control: PC1 análisis y diseño (02/10), PC2 código (30/10), PC3 pruebas y documentación (13/11). Cada cierre deja un tag en Git.</a:t>
             </a:r>
           </a:p>
         </p:txBody>
@@ -17743,7 +17743,7 @@
                 <a:ea typeface="Calibri" pitchFamily="34" charset="-122"/>
                 <a:cs typeface="Calibri" pitchFamily="34" charset="-120"/>
               </a:rPr>
-              <a:t>Próximo: PC2 · 20/11/26 — </a:t>
+              <a:t>Próximo: PC2 · 30/10/26 — </a:t>
             </a:r>
             <a:r>
               <a:rPr lang="en-US" sz="1800" dirty="0">

</xml_diff>